<commit_message>
Update PowerPoint for song #182 in FUBC - Українські
</commit_message>
<xml_diff>
--- a/fubc-ua/182-Ісуса люблю я (Пісні Спасенних №180).pptx
+++ b/fubc-ua/182-Ісуса люблю я (Пісні Спасенних №180).pptx
@@ -1469,7 +1469,7 @@
         </p:nvSpPr>
         <p:spPr>
           <a:xfrm>
-            <a:off x="2147214" y="2755392"/>
+            <a:off x="2246274" y="2755392"/>
             <a:ext cx="0" cy="2971800"/>
           </a:xfrm>
           <a:prstGeom prst="line">
@@ -1492,7 +1492,7 @@
         </p:nvSpPr>
         <p:spPr>
           <a:xfrm>
-            <a:off x="10050882" y="2755392"/>
+            <a:off x="9951822" y="2755392"/>
             <a:ext cx="0" cy="2971800"/>
           </a:xfrm>
           <a:prstGeom prst="line">
@@ -1515,8 +1515,8 @@
         </p:nvSpPr>
         <p:spPr>
           <a:xfrm>
-            <a:off x="10182962" y="4010152"/>
-            <a:ext cx="792480" cy="462280"/>
+            <a:off x="10050882" y="3921252"/>
+            <a:ext cx="1097280" cy="640080"/>
           </a:xfrm>
           <a:prstGeom prst="rect">
             <a:avLst/>
@@ -1532,9 +1532,9 @@
               <a:buNone/>
             </a:pPr>
             <a:r>
-              <a:rPr lang="en-US" sz="2600" b="1" dirty="0">
+              <a:rPr lang="en-US" sz="3600" b="1" dirty="0">
                 <a:solidFill>
-                  <a:srgbClr val="8A8A8A"/>
+                  <a:srgbClr val="BBBBBB"/>
                 </a:solidFill>
                 <a:latin typeface="Arial" pitchFamily="34" charset="0"/>
                 <a:ea typeface="Arial" pitchFamily="34" charset="-122"/>
@@ -1542,7 +1542,7 @@
               </a:rPr>
               <a:t>×2</a:t>
             </a:r>
-            <a:endParaRPr lang="en-US" sz="2600" dirty="0"/>
+            <a:endParaRPr lang="en-US" sz="3600" dirty="0"/>
           </a:p>
         </p:txBody>
       </p:sp>
@@ -1728,7 +1728,7 @@
         </p:nvSpPr>
         <p:spPr>
           <a:xfrm>
-            <a:off x="2439111" y="2755392"/>
+            <a:off x="2538171" y="2755392"/>
             <a:ext cx="0" cy="2971800"/>
           </a:xfrm>
           <a:prstGeom prst="line">
@@ -1751,7 +1751,7 @@
         </p:nvSpPr>
         <p:spPr>
           <a:xfrm>
-            <a:off x="9758985" y="2755392"/>
+            <a:off x="9659925" y="2755392"/>
             <a:ext cx="0" cy="2971800"/>
           </a:xfrm>
           <a:prstGeom prst="line">
@@ -1774,8 +1774,8 @@
         </p:nvSpPr>
         <p:spPr>
           <a:xfrm>
-            <a:off x="9891065" y="4010152"/>
-            <a:ext cx="792480" cy="462280"/>
+            <a:off x="9758985" y="3921252"/>
+            <a:ext cx="1097280" cy="640080"/>
           </a:xfrm>
           <a:prstGeom prst="rect">
             <a:avLst/>
@@ -1791,9 +1791,9 @@
               <a:buNone/>
             </a:pPr>
             <a:r>
-              <a:rPr lang="en-US" sz="2600" b="1" dirty="0">
+              <a:rPr lang="en-US" sz="3600" b="1" dirty="0">
                 <a:solidFill>
-                  <a:srgbClr val="8A8A8A"/>
+                  <a:srgbClr val="BBBBBB"/>
                 </a:solidFill>
                 <a:latin typeface="Arial" pitchFamily="34" charset="0"/>
                 <a:ea typeface="Arial" pitchFamily="34" charset="-122"/>
@@ -1801,7 +1801,7 @@
               </a:rPr>
               <a:t>×2</a:t>
             </a:r>
-            <a:endParaRPr lang="en-US" sz="2600" dirty="0"/>
+            <a:endParaRPr lang="en-US" sz="3600" dirty="0"/>
           </a:p>
         </p:txBody>
       </p:sp>
@@ -2007,7 +2007,7 @@
         </p:nvSpPr>
         <p:spPr>
           <a:xfrm>
-            <a:off x="2149526" y="3151632"/>
+            <a:off x="2248586" y="3151632"/>
             <a:ext cx="0" cy="2971800"/>
           </a:xfrm>
           <a:prstGeom prst="line">
@@ -2030,7 +2030,7 @@
         </p:nvSpPr>
         <p:spPr>
           <a:xfrm>
-            <a:off x="10048570" y="3151632"/>
+            <a:off x="9949510" y="3151632"/>
             <a:ext cx="0" cy="2971800"/>
           </a:xfrm>
           <a:prstGeom prst="line">
@@ -2053,8 +2053,8 @@
         </p:nvSpPr>
         <p:spPr>
           <a:xfrm>
-            <a:off x="10180650" y="4406392"/>
-            <a:ext cx="792480" cy="462280"/>
+            <a:off x="10048570" y="4317492"/>
+            <a:ext cx="1097280" cy="640080"/>
           </a:xfrm>
           <a:prstGeom prst="rect">
             <a:avLst/>
@@ -2070,9 +2070,9 @@
               <a:buNone/>
             </a:pPr>
             <a:r>
-              <a:rPr lang="en-US" sz="2600" b="1" dirty="0">
+              <a:rPr lang="en-US" sz="3600" b="1" dirty="0">
                 <a:solidFill>
-                  <a:srgbClr val="8A8A8A"/>
+                  <a:srgbClr val="BBBBBB"/>
                 </a:solidFill>
                 <a:latin typeface="Arial" pitchFamily="34" charset="0"/>
                 <a:ea typeface="Arial" pitchFamily="34" charset="-122"/>
@@ -2080,7 +2080,7 @@
               </a:rPr>
               <a:t>×2</a:t>
             </a:r>
-            <a:endParaRPr lang="en-US" sz="2600" dirty="0"/>
+            <a:endParaRPr lang="en-US" sz="3600" dirty="0"/>
           </a:p>
         </p:txBody>
       </p:sp>

</xml_diff>